<commit_message>
feat: complete PriorityCare implementation with FastAPI backend, Dijkstra routing, triage engine, and React Leaflet dashboard
</commit_message>
<xml_diff>
--- a/Priority-108(PPT).pptx
+++ b/Priority-108(PPT).pptx
@@ -2332,7 +2332,7 @@
         <p:spPr>
           <a:xfrm>
             <a:off x="5197110" y="3545987"/>
-            <a:ext cx="8364855" cy="1153160"/>
+            <a:ext cx="8364855" cy="1028487"/>
           </a:xfrm>
           <a:prstGeom prst="rect">
             <a:avLst/>
@@ -2353,16 +2353,25 @@
               </a:spcBef>
             </a:pPr>
             <a:r>
-              <a:rPr lang="en-US" sz="7400" b="1" dirty="0">
-                <a:solidFill>
-                  <a:srgbClr val="FFFFFF"/>
-                </a:solidFill>
-                <a:latin typeface="Cambria"/>
-                <a:cs typeface="Cambria"/>
-              </a:rPr>
-              <a:t>Priority 108</a:t>
-            </a:r>
-            <a:endParaRPr sz="7400" dirty="0">
+              <a:rPr lang="en-IN" sz="6600" b="1">
+                <a:solidFill>
+                  <a:schemeClr val="bg1"/>
+                </a:solidFill>
+              </a:rPr>
+              <a:t>INTELLATHON </a:t>
+            </a:r>
+            <a:r>
+              <a:rPr lang="en-IN" sz="6600" b="1" dirty="0">
+                <a:solidFill>
+                  <a:schemeClr val="bg1"/>
+                </a:solidFill>
+              </a:rPr>
+              <a:t>-26</a:t>
+            </a:r>
+            <a:endParaRPr sz="6600" b="1" dirty="0">
+              <a:solidFill>
+                <a:schemeClr val="bg1"/>
+              </a:solidFill>
               <a:latin typeface="Cambria"/>
               <a:cs typeface="Cambria"/>
             </a:endParaRPr>

</xml_diff>